<commit_message>
Add verified research report and research materials appendix
Co-Authored-By: Claude Opus 5.5 <noreply@anthropic.com>
Claude-Session: https://claude.ai/code/session_01VJzFUBPLqmq3ufk4M9DBQh
</commit_message>
<xml_diff>
--- a/ingosight/IngoKey_INGOSIGHT_2026.pptx
+++ b/ingosight/IngoKey_INGOSIGHT_2026.pptx
@@ -133,20 +133,20 @@
   <p:extLst>
     <p:ext uri="{521415D9-36F7-43E2-AB2F-B90AF26B5E84}">
       <p14:sectionLst xmlns:p14="http://schemas.microsoft.com/office/powerpoint/2010/main">
-        <p14:section name="Вступление" id="{3d3de02c-575f-19d1-648d-145f7d033394}">
+        <p14:section name="Вступление" id="{3706ff65-30a5-75c2-2d0f-93055dde2a0c}">
           <p14:sldIdLst>
             <p14:sldId id="256"/>
             <p14:sldId id="257"/>
             <p14:sldId id="258"/>
           </p14:sldIdLst>
         </p14:section>
-        <p14:section name="Сегмент и задача" id="{de183ce4-78cd-2a19-c756-3d8c828a82b6}">
+        <p14:section name="Сегмент и задача" id="{03349e35-6f3e-3760-aa49-ed18c5e7a910}">
           <p14:sldIdLst>
             <p14:sldId id="259"/>
             <p14:sldId id="260"/>
           </p14:sldIdLst>
         </p14:section>
-        <p14:section name="Подтверждение проблемы" id="{1d45d21b-8875-0f62-152d-da8772fc22e0}">
+        <p14:section name="Подтверждение проблемы" id="{5e982be9-8567-866f-0b63-b60a1a01f734}">
           <p14:sldIdLst>
             <p14:sldId id="261"/>
             <p14:sldId id="262"/>
@@ -156,7 +156,7 @@
             <p14:sldId id="266"/>
           </p14:sldIdLst>
         </p14:section>
-        <p14:section name="Альтернативы и привлекательность" id="{4622f557-cdf5-d93d-6fc3-3298c0c8f3fa}">
+        <p14:section name="Альтернативы и привлекательность" id="{c3b67157-35f4-c4ec-03aa-e1e95d047b1f}">
           <p14:sldIdLst>
             <p14:sldId id="267"/>
             <p14:sldId id="268"/>
@@ -164,7 +164,7 @@
             <p14:sldId id="270"/>
           </p14:sldIdLst>
         </p14:section>
-        <p14:section name="Решение" id="{3d9eb62c-bd30-ab11-b8a8-122279d8773f}">
+        <p14:section name="Решение" id="{239e30c0-a5c5-0271-e7b7-4989b056dae8}">
           <p14:sldIdLst>
             <p14:sldId id="271"/>
             <p14:sldId id="272"/>
@@ -172,7 +172,7 @@
             <p14:sldId id="274"/>
           </p14:sldIdLst>
         </p14:section>
-        <p14:section name="Бизнес-модель и финал" id="{740268c7-db52-d1f1-a513-c94cc7830a79}">
+        <p14:section name="Бизнес-модель и финал" id="{58041a8b-d026-50cc-a73f-5df05ca558cf}">
           <p14:sldIdLst>
             <p14:sldId id="275"/>
             <p14:sldId id="276"/>
@@ -18397,7 +18397,7 @@
                   <a:schemeClr val="bg1"/>
                 </a:solidFill>
               </a:rPr>
-              <a:t>КИД до заключения договора (Указание Банка России 6109-У), период охлаждения 14 дней (3854-У), электронный полис и акт с подписями. Сбор жильца оформляем отдельно от премии. Квалификацию неуплаты как финансового риска проверяем с юристами Ингосстраха.</a:t>
+              <a:t>КИД до заключения договора (6109-У), период охлаждения 14 дней (3854-У), электронный полис и акт с подписями. Невозвратной делаем только сервисную часть сбора, премия возвращается по правилам периода охлаждения. Квалификацию неуплаты как финансового риска проверяем с юристами Ингосстраха.</a:t>
             </a:r>
             <a:endParaRPr lang="en-US" sz="1050" dirty="0"/>
           </a:p>
@@ -23086,7 +23086,7 @@
                   <a:schemeClr val="bg1"/>
                 </a:solidFill>
               </a:rPr>
-              <a:t>Безубыточная частота выплат в базовом сценарии 43,5%. Частота, взыскание и веса смеси выплат - допущения, их проверяем в пилоте.</a:t>
+              <a:t>Безубыточность в базе: частота до 43,5%, взыскание от 19,2%, канал до 38,3%. При комиссии Ингосстраха по имуществу граждан 39,8% база дает 101,5%, поэтому нужен свой цифровой канал.</a:t>
             </a:r>
             <a:endParaRPr lang="en-US" sz="950" dirty="0"/>
           </a:p>

</xml_diff>